<commit_message>
added + some updates.
</commit_message>
<xml_diff>
--- a/slides/Lecture_Chapter03.pptx
+++ b/slides/Lecture_Chapter03.pptx
@@ -300,7 +300,7 @@
           <a:p>
             <a:fld id="{3E22BF2E-04DA-469E-97C5-BB68A0368813}" type="datetimeFigureOut">
               <a:rPr lang="en-US" smtClean="0"/>
-              <a:t>9/18/2025</a:t>
+              <a:t>11/29/2025</a:t>
             </a:fld>
             <a:endParaRPr lang="en-US"/>
           </a:p>
@@ -498,7 +498,7 @@
           <a:p>
             <a:fld id="{3E22BF2E-04DA-469E-97C5-BB68A0368813}" type="datetimeFigureOut">
               <a:rPr lang="en-US" smtClean="0"/>
-              <a:t>9/18/2025</a:t>
+              <a:t>11/29/2025</a:t>
             </a:fld>
             <a:endParaRPr lang="en-US"/>
           </a:p>
@@ -706,7 +706,7 @@
           <a:p>
             <a:fld id="{3E22BF2E-04DA-469E-97C5-BB68A0368813}" type="datetimeFigureOut">
               <a:rPr lang="en-US" smtClean="0"/>
-              <a:t>9/18/2025</a:t>
+              <a:t>11/29/2025</a:t>
             </a:fld>
             <a:endParaRPr lang="en-US"/>
           </a:p>
@@ -914,7 +914,7 @@
           <a:p>
             <a:fld id="{3E22BF2E-04DA-469E-97C5-BB68A0368813}" type="datetimeFigureOut">
               <a:rPr lang="en-US" smtClean="0"/>
-              <a:t>9/18/2025</a:t>
+              <a:t>11/29/2025</a:t>
             </a:fld>
             <a:endParaRPr lang="en-US"/>
           </a:p>
@@ -1189,7 +1189,7 @@
           <a:p>
             <a:fld id="{3E22BF2E-04DA-469E-97C5-BB68A0368813}" type="datetimeFigureOut">
               <a:rPr lang="en-US" smtClean="0"/>
-              <a:t>9/18/2025</a:t>
+              <a:t>11/29/2025</a:t>
             </a:fld>
             <a:endParaRPr lang="en-US"/>
           </a:p>
@@ -1454,7 +1454,7 @@
           <a:p>
             <a:fld id="{3E22BF2E-04DA-469E-97C5-BB68A0368813}" type="datetimeFigureOut">
               <a:rPr lang="en-US" smtClean="0"/>
-              <a:t>9/18/2025</a:t>
+              <a:t>11/29/2025</a:t>
             </a:fld>
             <a:endParaRPr lang="en-US"/>
           </a:p>
@@ -1866,7 +1866,7 @@
           <a:p>
             <a:fld id="{3E22BF2E-04DA-469E-97C5-BB68A0368813}" type="datetimeFigureOut">
               <a:rPr lang="en-US" smtClean="0"/>
-              <a:t>9/18/2025</a:t>
+              <a:t>11/29/2025</a:t>
             </a:fld>
             <a:endParaRPr lang="en-US"/>
           </a:p>
@@ -2007,7 +2007,7 @@
           <a:p>
             <a:fld id="{3E22BF2E-04DA-469E-97C5-BB68A0368813}" type="datetimeFigureOut">
               <a:rPr lang="en-US" smtClean="0"/>
-              <a:t>9/18/2025</a:t>
+              <a:t>11/29/2025</a:t>
             </a:fld>
             <a:endParaRPr lang="en-US"/>
           </a:p>
@@ -2120,7 +2120,7 @@
           <a:p>
             <a:fld id="{3E22BF2E-04DA-469E-97C5-BB68A0368813}" type="datetimeFigureOut">
               <a:rPr lang="en-US" smtClean="0"/>
-              <a:t>9/18/2025</a:t>
+              <a:t>11/29/2025</a:t>
             </a:fld>
             <a:endParaRPr lang="en-US"/>
           </a:p>
@@ -2431,7 +2431,7 @@
           <a:p>
             <a:fld id="{3E22BF2E-04DA-469E-97C5-BB68A0368813}" type="datetimeFigureOut">
               <a:rPr lang="en-US" smtClean="0"/>
-              <a:t>9/18/2025</a:t>
+              <a:t>11/29/2025</a:t>
             </a:fld>
             <a:endParaRPr lang="en-US"/>
           </a:p>
@@ -2719,7 +2719,7 @@
           <a:p>
             <a:fld id="{3E22BF2E-04DA-469E-97C5-BB68A0368813}" type="datetimeFigureOut">
               <a:rPr lang="en-US" smtClean="0"/>
-              <a:t>9/18/2025</a:t>
+              <a:t>11/29/2025</a:t>
             </a:fld>
             <a:endParaRPr lang="en-US"/>
           </a:p>
@@ -2960,7 +2960,7 @@
           <a:p>
             <a:fld id="{3E22BF2E-04DA-469E-97C5-BB68A0368813}" type="datetimeFigureOut">
               <a:rPr lang="en-US" smtClean="0"/>
-              <a:t>9/18/2025</a:t>
+              <a:t>11/29/2025</a:t>
             </a:fld>
             <a:endParaRPr lang="en-US"/>
           </a:p>
@@ -3937,6 +3937,53 @@
           </a:prstGeom>
         </p:spPr>
       </p:pic>
+      <p:pic>
+        <p:nvPicPr>
+          <p:cNvPr id="6" name="Picture 4">
+            <a:extLst>
+              <a:ext uri="{FF2B5EF4-FFF2-40B4-BE49-F238E27FC236}">
+                <a16:creationId xmlns:a16="http://schemas.microsoft.com/office/drawing/2014/main" id="{A9F9786C-76AC-22A8-2028-BB0A9E3784F6}"/>
+              </a:ext>
+            </a:extLst>
+          </p:cNvPr>
+          <p:cNvPicPr>
+            <a:picLocks noChangeAspect="1" noChangeArrowheads="1"/>
+          </p:cNvPicPr>
+          <p:nvPr/>
+        </p:nvPicPr>
+        <p:blipFill>
+          <a:blip r:embed="rId5">
+            <a:extLst>
+              <a:ext uri="{28A0092B-C50C-407E-A947-70E740481C1C}">
+                <a14:useLocalDpi xmlns:a14="http://schemas.microsoft.com/office/drawing/2010/main" val="0"/>
+              </a:ext>
+            </a:extLst>
+          </a:blip>
+          <a:srcRect/>
+          <a:stretch>
+            <a:fillRect/>
+          </a:stretch>
+        </p:blipFill>
+        <p:spPr bwMode="auto">
+          <a:xfrm>
+            <a:off x="7987456" y="125210"/>
+            <a:ext cx="4182403" cy="1000945"/>
+          </a:xfrm>
+          <a:prstGeom prst="rect">
+            <a:avLst/>
+          </a:prstGeom>
+          <a:noFill/>
+          <a:extLst>
+            <a:ext uri="{909E8E84-426E-40DD-AFC4-6F175D3DCCD1}">
+              <a14:hiddenFill xmlns:a14="http://schemas.microsoft.com/office/drawing/2010/main">
+                <a:solidFill>
+                  <a:srgbClr val="FFFFFF"/>
+                </a:solidFill>
+              </a14:hiddenFill>
+            </a:ext>
+          </a:extLst>
+        </p:spPr>
+      </p:pic>
     </p:spTree>
     <p:extLst>
       <p:ext uri="{BB962C8B-B14F-4D97-AF65-F5344CB8AC3E}">

</xml_diff>